<commit_message>
Fix corrupt PPTX: insert dashboard slide surgically (preserve original parts)
이전 pptx는 python-pptx가 전체 파트를 재직렬화하면서 PowerPoint가 열 수 없는
상태가 되었다(원본 슬라이드까지 재작성됨). 이를 원본 zip에 슬라이드 1개만
외과적으로 추가하는 방식으로 교체:
 - 기존 8개 슬라이드·미디어·관계를 바이트 그대로 보존
 - 신호등 UI(슬라이드 7) 뒤에 대시보드 슬라이드(전체 이미지) 삽입
 - [Content_Types]·presentation.xml·rels 최소 편집만 수행
전체 슬라이드는 Chromium 렌더(한글 정상)로 단일 이미지화하여 삽입.

Co-Authored-By: Claude Opus 4.8 <noreply@anthropic.com>
Claude-Session: https://claude.ai/code/session_01RcPFArU2bWS58UppnxUvHh
</commit_message>
<xml_diff>
--- a/outputs/BioGuard-AI_presentation.pptx
+++ b/outputs/BioGuard-AI_presentation.pptx
@@ -15,7 +15,7 @@
     <p:sldId id="260" r:id="rId13"/>
     <p:sldId id="261" r:id="rId14"/>
     <p:sldId id="262" r:id="rId15"/>
-    <p:sldId id="265" r:id="rId8"/>
+    <p:sldId id="266" r:id="rId26"/>
     <p:sldId id="263" r:id="rId16"/>
   </p:sldIdLst>
   <p:notesMasterIdLst/>
@@ -12287,7 +12287,7 @@
 </file>
 
 <file path=ppt/slides/slide9.xml><?xml version="1.0" encoding="utf-8"?>
-<p:sld xmlns:a="http://schemas.openxmlformats.org/drawingml/2006/main" xmlns:p="http://schemas.openxmlformats.org/presentationml/2006/main" xmlns:r="http://schemas.openxmlformats.org/officeDocument/2006/relationships">
+<p:sld xmlns:a="http://schemas.openxmlformats.org/drawingml/2006/main" xmlns:r="http://schemas.openxmlformats.org/officeDocument/2006/relationships" xmlns:p="http://schemas.openxmlformats.org/presentationml/2006/main">
   <p:cSld>
     <p:spTree>
       <p:nvGrpSpPr>
@@ -12295,169 +12295,17 @@
         <p:cNvGrpSpPr/>
         <p:nvPr/>
       </p:nvGrpSpPr>
-      <p:grpSpPr/>
-      <p:sp>
-        <p:nvSpPr>
-          <p:cNvPr id="2" name="Rectangle 1"/>
-          <p:cNvSpPr/>
-          <p:nvPr/>
-        </p:nvSpPr>
-        <p:spPr>
-          <a:xfrm>
-            <a:off x="0" y="0"/>
-            <a:ext cx="12192000" cy="6858000"/>
-          </a:xfrm>
-          <a:prstGeom prst="rect">
-            <a:avLst/>
-          </a:prstGeom>
-          <a:solidFill>
-            <a:srgbClr val="FFFFFF"/>
-          </a:solidFill>
-          <a:ln>
-            <a:noFill/>
-          </a:ln>
-          <a:effectLst/>
-        </p:spPr>
-        <p:style>
-          <a:lnRef idx="1">
-            <a:schemeClr val="accent1"/>
-          </a:lnRef>
-          <a:fillRef idx="3">
-            <a:schemeClr val="accent1"/>
-          </a:fillRef>
-          <a:effectRef idx="2">
-            <a:schemeClr val="accent1"/>
-          </a:effectRef>
-          <a:fontRef idx="minor">
-            <a:schemeClr val="lt1"/>
-          </a:fontRef>
-        </p:style>
-        <p:txBody>
-          <a:bodyPr rtlCol="0" anchor="ctr"/>
-          <a:lstStyle/>
-          <a:p>
-            <a:pPr algn="ctr"/>
-          </a:p>
-        </p:txBody>
-      </p:sp>
-      <p:sp>
-        <p:nvSpPr>
-          <p:cNvPr id="3" name="TextBox 2"/>
-          <p:cNvSpPr txBox="1"/>
-          <p:nvPr/>
-        </p:nvSpPr>
-        <p:spPr>
-          <a:xfrm>
-            <a:off x="667512" y="457200"/>
-            <a:ext cx="5486400" cy="274320"/>
-          </a:xfrm>
-          <a:prstGeom prst="rect">
-            <a:avLst/>
-          </a:prstGeom>
-          <a:noFill/>
-        </p:spPr>
-        <p:txBody>
-          <a:bodyPr wrap="square" lIns="0" tIns="0" rIns="0" bIns="0">
-            <a:spAutoFit/>
-          </a:bodyPr>
-          <a:lstStyle/>
-          <a:p>
-            <a:pPr algn="l"/>
-            <a:r>
-              <a:rPr sz="1300" b="1">
-                <a:solidFill>
-                  <a:srgbClr val="1C8F74"/>
-                </a:solidFill>
-                <a:latin typeface="Pretendard"/>
-              </a:rPr>
-              <a:t>LIVE DASHBOARD</a:t>
-            </a:r>
-          </a:p>
-        </p:txBody>
-      </p:sp>
-      <p:sp>
-        <p:nvSpPr>
-          <p:cNvPr id="4" name="TextBox 3"/>
-          <p:cNvSpPr txBox="1"/>
-          <p:nvPr/>
-        </p:nvSpPr>
-        <p:spPr>
-          <a:xfrm>
-            <a:off x="667512" y="804672"/>
-            <a:ext cx="10972800" cy="548640"/>
-          </a:xfrm>
-          <a:prstGeom prst="rect">
-            <a:avLst/>
-          </a:prstGeom>
-          <a:noFill/>
-        </p:spPr>
-        <p:txBody>
-          <a:bodyPr wrap="square" lIns="0" tIns="0" rIns="0" bIns="0">
-            <a:spAutoFit/>
-          </a:bodyPr>
-          <a:lstStyle/>
-          <a:p>
-            <a:pPr algn="l"/>
-            <a:r>
-              <a:rPr sz="3000" b="1">
-                <a:solidFill>
-                  <a:srgbClr val="1A1A2E"/>
-                </a:solidFill>
-                <a:latin typeface="Pretendard"/>
-              </a:rPr>
-              <a:t>BioGuard-AI 관제 대시보드</a:t>
-            </a:r>
-          </a:p>
-        </p:txBody>
-      </p:sp>
-      <p:sp>
-        <p:nvSpPr>
-          <p:cNvPr id="5" name="Rounded Rectangle 4"/>
-          <p:cNvSpPr/>
-          <p:nvPr/>
-        </p:nvSpPr>
-        <p:spPr>
-          <a:xfrm>
-            <a:off x="594359" y="1691639"/>
-            <a:ext cx="6120296" cy="4617720"/>
-          </a:xfrm>
-          <a:prstGeom prst="roundRect">
-            <a:avLst/>
-          </a:prstGeom>
-          <a:solidFill>
-            <a:srgbClr val="0C1413"/>
-          </a:solidFill>
-          <a:ln w="12700">
-            <a:solidFill>
-              <a:srgbClr val="24332E"/>
-            </a:solidFill>
-          </a:ln>
-        </p:spPr>
-        <p:style>
-          <a:lnRef idx="1">
-            <a:schemeClr val="accent1"/>
-          </a:lnRef>
-          <a:fillRef idx="3">
-            <a:schemeClr val="accent1"/>
-          </a:fillRef>
-          <a:effectRef idx="2">
-            <a:schemeClr val="accent1"/>
-          </a:effectRef>
-          <a:fontRef idx="minor">
-            <a:schemeClr val="lt1"/>
-          </a:fontRef>
-        </p:style>
-        <p:txBody>
-          <a:bodyPr rtlCol="0" anchor="ctr"/>
-          <a:lstStyle/>
-          <a:p>
-            <a:pPr algn="ctr"/>
-          </a:p>
-        </p:txBody>
-      </p:sp>
+      <p:grpSpPr>
+        <a:xfrm>
+          <a:off x="0" y="0"/>
+          <a:ext cx="0" cy="0"/>
+          <a:chOff x="0" y="0"/>
+          <a:chExt cx="0" cy="0"/>
+        </a:xfrm>
+      </p:grpSpPr>
       <p:pic>
         <p:nvPicPr>
-          <p:cNvPr id="6" name="Picture 5" descr="dash_ppt.png"/>
+          <p:cNvPr id="2" name="Dashboard"/>
           <p:cNvPicPr>
             <a:picLocks noChangeAspect="1"/>
           </p:cNvPicPr>
@@ -12471,540 +12319,14 @@
         </p:blipFill>
         <p:spPr>
           <a:xfrm>
-            <a:off x="640080" y="1737360"/>
-            <a:ext cx="6028856" cy="4526280"/>
+            <a:off x="0" y="0"/>
+            <a:ext cx="12192000" cy="6858000"/>
           </a:xfrm>
           <a:prstGeom prst="rect">
             <a:avLst/>
           </a:prstGeom>
         </p:spPr>
       </p:pic>
-      <p:sp>
-        <p:nvSpPr>
-          <p:cNvPr id="7" name="TextBox 6"/>
-          <p:cNvSpPr txBox="1"/>
-          <p:nvPr/>
-        </p:nvSpPr>
-        <p:spPr>
-          <a:xfrm>
-            <a:off x="640080" y="6373368"/>
-            <a:ext cx="6028856" cy="274320"/>
-          </a:xfrm>
-          <a:prstGeom prst="rect">
-            <a:avLst/>
-          </a:prstGeom>
-          <a:noFill/>
-        </p:spPr>
-        <p:txBody>
-          <a:bodyPr wrap="square" lIns="0" tIns="0" rIns="0" bIns="0">
-            <a:spAutoFit/>
-          </a:bodyPr>
-          <a:lstStyle/>
-          <a:p>
-            <a:pPr algn="l"/>
-            <a:r>
-              <a:rPr sz="1050" b="0">
-                <a:solidFill>
-                  <a:srgbClr val="5A6A7A"/>
-                </a:solidFill>
-                <a:latin typeface="Pretendard"/>
-              </a:rPr>
-              <a:t>실제 2023년 홀드아웃 예측으로 렌더링 — 메탄생성량 + VFA/알칼리도 건강 신호등</a:t>
-            </a:r>
-          </a:p>
-        </p:txBody>
-      </p:sp>
-      <p:sp>
-        <p:nvSpPr>
-          <p:cNvPr id="8" name="Rounded Rectangle 7"/>
-          <p:cNvSpPr/>
-          <p:nvPr/>
-        </p:nvSpPr>
-        <p:spPr>
-          <a:xfrm>
-            <a:off x="7171856" y="1828800"/>
-            <a:ext cx="64008" cy="859536"/>
-          </a:xfrm>
-          <a:prstGeom prst="roundRect">
-            <a:avLst/>
-          </a:prstGeom>
-          <a:solidFill>
-            <a:srgbClr val="1C8F74"/>
-          </a:solidFill>
-          <a:ln>
-            <a:noFill/>
-          </a:ln>
-          <a:effectLst/>
-        </p:spPr>
-        <p:style>
-          <a:lnRef idx="1">
-            <a:schemeClr val="accent1"/>
-          </a:lnRef>
-          <a:fillRef idx="3">
-            <a:schemeClr val="accent1"/>
-          </a:fillRef>
-          <a:effectRef idx="2">
-            <a:schemeClr val="accent1"/>
-          </a:effectRef>
-          <a:fontRef idx="minor">
-            <a:schemeClr val="lt1"/>
-          </a:fontRef>
-        </p:style>
-        <p:txBody>
-          <a:bodyPr rtlCol="0" anchor="ctr"/>
-          <a:lstStyle/>
-          <a:p>
-            <a:pPr algn="ctr"/>
-          </a:p>
-        </p:txBody>
-      </p:sp>
-      <p:sp>
-        <p:nvSpPr>
-          <p:cNvPr id="9" name="TextBox 8"/>
-          <p:cNvSpPr txBox="1"/>
-          <p:nvPr/>
-        </p:nvSpPr>
-        <p:spPr>
-          <a:xfrm>
-            <a:off x="7373024" y="1828800"/>
-            <a:ext cx="4267287" cy="310896"/>
-          </a:xfrm>
-          <a:prstGeom prst="rect">
-            <a:avLst/>
-          </a:prstGeom>
-          <a:noFill/>
-        </p:spPr>
-        <p:txBody>
-          <a:bodyPr wrap="square" lIns="0" tIns="0" rIns="0" bIns="0">
-            <a:spAutoFit/>
-          </a:bodyPr>
-          <a:lstStyle/>
-          <a:p>
-            <a:pPr algn="l"/>
-            <a:r>
-              <a:rPr sz="1450" b="1">
-                <a:solidFill>
-                  <a:srgbClr val="1A1A2E"/>
-                </a:solidFill>
-                <a:latin typeface="Pretendard"/>
-              </a:rPr>
-              <a:t>🟢  신호등 건강 관제</a:t>
-            </a:r>
-          </a:p>
-        </p:txBody>
-      </p:sp>
-      <p:sp>
-        <p:nvSpPr>
-          <p:cNvPr id="10" name="TextBox 9"/>
-          <p:cNvSpPr txBox="1"/>
-          <p:nvPr/>
-        </p:nvSpPr>
-        <p:spPr>
-          <a:xfrm>
-            <a:off x="7373024" y="2212848"/>
-            <a:ext cx="4267287" cy="548640"/>
-          </a:xfrm>
-          <a:prstGeom prst="rect">
-            <a:avLst/>
-          </a:prstGeom>
-          <a:noFill/>
-        </p:spPr>
-        <p:txBody>
-          <a:bodyPr wrap="square" lIns="0" tIns="0" rIns="0" bIns="0">
-            <a:spAutoFit/>
-          </a:bodyPr>
-          <a:lstStyle/>
-          <a:p>
-            <a:pPr algn="l"/>
-            <a:r>
-              <a:rPr sz="1150" b="0">
-                <a:solidFill>
-                  <a:srgbClr val="5A6A7A"/>
-                </a:solidFill>
-                <a:latin typeface="Pretendard"/>
-              </a:rPr>
-              <a:t>VFA/알칼리도 기반 4단계(안정·주의·불안정·위험) 실시간 판정</a:t>
-            </a:r>
-          </a:p>
-        </p:txBody>
-      </p:sp>
-      <p:sp>
-        <p:nvSpPr>
-          <p:cNvPr id="11" name="Rounded Rectangle 10"/>
-          <p:cNvSpPr/>
-          <p:nvPr/>
-        </p:nvSpPr>
-        <p:spPr>
-          <a:xfrm>
-            <a:off x="7171856" y="2852928"/>
-            <a:ext cx="64008" cy="859536"/>
-          </a:xfrm>
-          <a:prstGeom prst="roundRect">
-            <a:avLst/>
-          </a:prstGeom>
-          <a:solidFill>
-            <a:srgbClr val="1C8F74"/>
-          </a:solidFill>
-          <a:ln>
-            <a:noFill/>
-          </a:ln>
-          <a:effectLst/>
-        </p:spPr>
-        <p:style>
-          <a:lnRef idx="1">
-            <a:schemeClr val="accent1"/>
-          </a:lnRef>
-          <a:fillRef idx="3">
-            <a:schemeClr val="accent1"/>
-          </a:fillRef>
-          <a:effectRef idx="2">
-            <a:schemeClr val="accent1"/>
-          </a:effectRef>
-          <a:fontRef idx="minor">
-            <a:schemeClr val="lt1"/>
-          </a:fontRef>
-        </p:style>
-        <p:txBody>
-          <a:bodyPr rtlCol="0" anchor="ctr"/>
-          <a:lstStyle/>
-          <a:p>
-            <a:pPr algn="ctr"/>
-          </a:p>
-        </p:txBody>
-      </p:sp>
-      <p:sp>
-        <p:nvSpPr>
-          <p:cNvPr id="12" name="TextBox 11"/>
-          <p:cNvSpPr txBox="1"/>
-          <p:nvPr/>
-        </p:nvSpPr>
-        <p:spPr>
-          <a:xfrm>
-            <a:off x="7373024" y="2852928"/>
-            <a:ext cx="4267287" cy="310896"/>
-          </a:xfrm>
-          <a:prstGeom prst="rect">
-            <a:avLst/>
-          </a:prstGeom>
-          <a:noFill/>
-        </p:spPr>
-        <p:txBody>
-          <a:bodyPr wrap="square" lIns="0" tIns="0" rIns="0" bIns="0">
-            <a:spAutoFit/>
-          </a:bodyPr>
-          <a:lstStyle/>
-          <a:p>
-            <a:pPr algn="l"/>
-            <a:r>
-              <a:rPr sz="1450" b="1">
-                <a:solidFill>
-                  <a:srgbClr val="1A1A2E"/>
-                </a:solidFill>
-                <a:latin typeface="Pretendard"/>
-              </a:rPr>
-              <a:t>📈  메탄생성량 예측</a:t>
-            </a:r>
-          </a:p>
-        </p:txBody>
-      </p:sp>
-      <p:sp>
-        <p:nvSpPr>
-          <p:cNvPr id="13" name="TextBox 12"/>
-          <p:cNvSpPr txBox="1"/>
-          <p:nvPr/>
-        </p:nvSpPr>
-        <p:spPr>
-          <a:xfrm>
-            <a:off x="7373024" y="3236976"/>
-            <a:ext cx="4267287" cy="548640"/>
-          </a:xfrm>
-          <a:prstGeom prst="rect">
-            <a:avLst/>
-          </a:prstGeom>
-          <a:noFill/>
-        </p:spPr>
-        <p:txBody>
-          <a:bodyPr wrap="square" lIns="0" tIns="0" rIns="0" bIns="0">
-            <a:spAutoFit/>
-          </a:bodyPr>
-          <a:lstStyle/>
-          <a:p>
-            <a:pPr algn="l"/>
-            <a:r>
-              <a:rPr sz="1150" b="0">
-                <a:solidFill>
-                  <a:srgbClr val="5A6A7A"/>
-                </a:solidFill>
-                <a:latin typeface="Pretendard"/>
-              </a:rPr>
-              <a:t>과거 부하 이력·소화조 상태로 당일 생성량을 추정, 실측 추종</a:t>
-            </a:r>
-          </a:p>
-        </p:txBody>
-      </p:sp>
-      <p:sp>
-        <p:nvSpPr>
-          <p:cNvPr id="14" name="Rounded Rectangle 13"/>
-          <p:cNvSpPr/>
-          <p:nvPr/>
-        </p:nvSpPr>
-        <p:spPr>
-          <a:xfrm>
-            <a:off x="7171856" y="3877056"/>
-            <a:ext cx="64008" cy="859536"/>
-          </a:xfrm>
-          <a:prstGeom prst="roundRect">
-            <a:avLst/>
-          </a:prstGeom>
-          <a:solidFill>
-            <a:srgbClr val="1C8F74"/>
-          </a:solidFill>
-          <a:ln>
-            <a:noFill/>
-          </a:ln>
-          <a:effectLst/>
-        </p:spPr>
-        <p:style>
-          <a:lnRef idx="1">
-            <a:schemeClr val="accent1"/>
-          </a:lnRef>
-          <a:fillRef idx="3">
-            <a:schemeClr val="accent1"/>
-          </a:fillRef>
-          <a:effectRef idx="2">
-            <a:schemeClr val="accent1"/>
-          </a:effectRef>
-          <a:fontRef idx="minor">
-            <a:schemeClr val="lt1"/>
-          </a:fontRef>
-        </p:style>
-        <p:txBody>
-          <a:bodyPr rtlCol="0" anchor="ctr"/>
-          <a:lstStyle/>
-          <a:p>
-            <a:pPr algn="ctr"/>
-          </a:p>
-        </p:txBody>
-      </p:sp>
-      <p:sp>
-        <p:nvSpPr>
-          <p:cNvPr id="15" name="TextBox 14"/>
-          <p:cNvSpPr txBox="1"/>
-          <p:nvPr/>
-        </p:nvSpPr>
-        <p:spPr>
-          <a:xfrm>
-            <a:off x="7373024" y="3877056"/>
-            <a:ext cx="4267287" cy="310896"/>
-          </a:xfrm>
-          <a:prstGeom prst="rect">
-            <a:avLst/>
-          </a:prstGeom>
-          <a:noFill/>
-        </p:spPr>
-        <p:txBody>
-          <a:bodyPr wrap="square" lIns="0" tIns="0" rIns="0" bIns="0">
-            <a:spAutoFit/>
-          </a:bodyPr>
-          <a:lstStyle/>
-          <a:p>
-            <a:pPr algn="l"/>
-            <a:r>
-              <a:rPr sz="1450" b="1">
-                <a:solidFill>
-                  <a:srgbClr val="1A1A2E"/>
-                </a:solidFill>
-                <a:latin typeface="Pretendard"/>
-              </a:rPr>
-              <a:t>🧪  산성화 조기경보</a:t>
-            </a:r>
-          </a:p>
-        </p:txBody>
-      </p:sp>
-      <p:sp>
-        <p:nvSpPr>
-          <p:cNvPr id="16" name="TextBox 15"/>
-          <p:cNvSpPr txBox="1"/>
-          <p:nvPr/>
-        </p:nvSpPr>
-        <p:spPr>
-          <a:xfrm>
-            <a:off x="7373024" y="4261104"/>
-            <a:ext cx="4267287" cy="548640"/>
-          </a:xfrm>
-          <a:prstGeom prst="rect">
-            <a:avLst/>
-          </a:prstGeom>
-          <a:noFill/>
-        </p:spPr>
-        <p:txBody>
-          <a:bodyPr wrap="square" lIns="0" tIns="0" rIns="0" bIns="0">
-            <a:spAutoFit/>
-          </a:bodyPr>
-          <a:lstStyle/>
-          <a:p>
-            <a:pPr algn="l"/>
-            <a:r>
-              <a:rPr sz="1150" b="0">
-                <a:solidFill>
-                  <a:srgbClr val="5A6A7A"/>
-                </a:solidFill>
-                <a:latin typeface="Pretendard"/>
-              </a:rPr>
-              <a:t>수율이 정상이어도 완충능 소진(VFA/ALK↑) 시 사전 경보</a:t>
-            </a:r>
-          </a:p>
-        </p:txBody>
-      </p:sp>
-      <p:sp>
-        <p:nvSpPr>
-          <p:cNvPr id="17" name="Rounded Rectangle 16"/>
-          <p:cNvSpPr/>
-          <p:nvPr/>
-        </p:nvSpPr>
-        <p:spPr>
-          <a:xfrm>
-            <a:off x="7171856" y="4901184"/>
-            <a:ext cx="64008" cy="859536"/>
-          </a:xfrm>
-          <a:prstGeom prst="roundRect">
-            <a:avLst/>
-          </a:prstGeom>
-          <a:solidFill>
-            <a:srgbClr val="1C8F74"/>
-          </a:solidFill>
-          <a:ln>
-            <a:noFill/>
-          </a:ln>
-          <a:effectLst/>
-        </p:spPr>
-        <p:style>
-          <a:lnRef idx="1">
-            <a:schemeClr val="accent1"/>
-          </a:lnRef>
-          <a:fillRef idx="3">
-            <a:schemeClr val="accent1"/>
-          </a:fillRef>
-          <a:effectRef idx="2">
-            <a:schemeClr val="accent1"/>
-          </a:effectRef>
-          <a:fontRef idx="minor">
-            <a:schemeClr val="lt1"/>
-          </a:fontRef>
-        </p:style>
-        <p:txBody>
-          <a:bodyPr rtlCol="0" anchor="ctr"/>
-          <a:lstStyle/>
-          <a:p>
-            <a:pPr algn="ctr"/>
-          </a:p>
-        </p:txBody>
-      </p:sp>
-      <p:sp>
-        <p:nvSpPr>
-          <p:cNvPr id="18" name="TextBox 17"/>
-          <p:cNvSpPr txBox="1"/>
-          <p:nvPr/>
-        </p:nvSpPr>
-        <p:spPr>
-          <a:xfrm>
-            <a:off x="7373024" y="4901184"/>
-            <a:ext cx="4267287" cy="310896"/>
-          </a:xfrm>
-          <a:prstGeom prst="rect">
-            <a:avLst/>
-          </a:prstGeom>
-          <a:noFill/>
-        </p:spPr>
-        <p:txBody>
-          <a:bodyPr wrap="square" lIns="0" tIns="0" rIns="0" bIns="0">
-            <a:spAutoFit/>
-          </a:bodyPr>
-          <a:lstStyle/>
-          <a:p>
-            <a:pPr algn="l"/>
-            <a:r>
-              <a:rPr sz="1450" b="1">
-                <a:solidFill>
-                  <a:srgbClr val="1A1A2E"/>
-                </a:solidFill>
-                <a:latin typeface="Pretendard"/>
-              </a:rPr>
-              <a:t>⚙️  AI 운전 가이드</a:t>
-            </a:r>
-          </a:p>
-        </p:txBody>
-      </p:sp>
-      <p:sp>
-        <p:nvSpPr>
-          <p:cNvPr id="19" name="TextBox 18"/>
-          <p:cNvSpPr txBox="1"/>
-          <p:nvPr/>
-        </p:nvSpPr>
-        <p:spPr>
-          <a:xfrm>
-            <a:off x="7373024" y="5285232"/>
-            <a:ext cx="4267287" cy="548640"/>
-          </a:xfrm>
-          <a:prstGeom prst="rect">
-            <a:avLst/>
-          </a:prstGeom>
-          <a:noFill/>
-        </p:spPr>
-        <p:txBody>
-          <a:bodyPr wrap="square" lIns="0" tIns="0" rIns="0" bIns="0">
-            <a:spAutoFit/>
-          </a:bodyPr>
-          <a:lstStyle/>
-          <a:p>
-            <a:pPr algn="l"/>
-            <a:r>
-              <a:rPr sz="1150" b="0">
-                <a:solidFill>
-                  <a:srgbClr val="5A6A7A"/>
-                </a:solidFill>
-                <a:latin typeface="Pretendard"/>
-              </a:rPr>
-              <a:t>과부하 회피 위한 유기물부하율·투입 조절 범위 제안</a:t>
-            </a:r>
-          </a:p>
-        </p:txBody>
-      </p:sp>
-      <p:sp>
-        <p:nvSpPr>
-          <p:cNvPr id="20" name="TextBox 19"/>
-          <p:cNvSpPr txBox="1"/>
-          <p:nvPr/>
-        </p:nvSpPr>
-        <p:spPr>
-          <a:xfrm>
-            <a:off x="7171856" y="5943600"/>
-            <a:ext cx="4468455" cy="457200"/>
-          </a:xfrm>
-          <a:prstGeom prst="rect">
-            <a:avLst/>
-          </a:prstGeom>
-          <a:noFill/>
-        </p:spPr>
-        <p:txBody>
-          <a:bodyPr wrap="square" lIns="0" tIns="0" rIns="0" bIns="0">
-            <a:spAutoFit/>
-          </a:bodyPr>
-          <a:lstStyle/>
-          <a:p>
-            <a:pPr algn="l"/>
-            <a:r>
-              <a:rPr sz="1050" b="1">
-                <a:solidFill>
-                  <a:srgbClr val="1C8F74"/>
-                </a:solidFill>
-                <a:latin typeface="Pretendard"/>
-              </a:rPr>
-              <a:t>Base: RF·MLP·LSTM·Transformer + NNLS 비음수 스태킹</a:t>
-            </a:r>
-          </a:p>
-        </p:txBody>
-      </p:sp>
     </p:spTree>
   </p:cSld>
   <p:clrMapOvr>

</xml_diff>